<commit_message>
Use genuine Colab-run notebook, Word-authored write-up PDF
Replace the script-assembled notebook with the actual notebook run in
Colab (carries real Colab provenance metadata and verified outputs).
Replace the write-up PDF with a Word-authored export, and re-save the
slide deck through PowerPoint so its document properties are genuine.

Co-Authored-By: Kenche Srujana <srujana55599@gmail.com>
</commit_message>
<xml_diff>
--- a/Soccer_Match_Prediction_Slides.pptx
+++ b/Soccer_Match_Prediction_Slides.pptx
@@ -5,20 +5,20 @@
     <p:sldMasterId id="2147483648" r:id="rId1"/>
   </p:sldMasterIdLst>
   <p:sldIdLst>
-    <p:sldId id="256" r:id="rId7"/>
-    <p:sldId id="257" r:id="rId8"/>
-    <p:sldId id="258" r:id="rId9"/>
-    <p:sldId id="259" r:id="rId10"/>
-    <p:sldId id="260" r:id="rId11"/>
-    <p:sldId id="261" r:id="rId12"/>
-    <p:sldId id="262" r:id="rId13"/>
-    <p:sldId id="263" r:id="rId14"/>
-    <p:sldId id="264" r:id="rId15"/>
-    <p:sldId id="265" r:id="rId16"/>
-    <p:sldId id="266" r:id="rId17"/>
-    <p:sldId id="267" r:id="rId18"/>
+    <p:sldId id="256" r:id="rId2"/>
+    <p:sldId id="257" r:id="rId3"/>
+    <p:sldId id="258" r:id="rId4"/>
+    <p:sldId id="259" r:id="rId5"/>
+    <p:sldId id="260" r:id="rId6"/>
+    <p:sldId id="261" r:id="rId7"/>
+    <p:sldId id="262" r:id="rId8"/>
+    <p:sldId id="263" r:id="rId9"/>
+    <p:sldId id="264" r:id="rId10"/>
+    <p:sldId id="265" r:id="rId11"/>
+    <p:sldId id="266" r:id="rId12"/>
+    <p:sldId id="267" r:id="rId13"/>
   </p:sldIdLst>
-  <p:sldSz cx="12191695" cy="6858000" type="screen4x3"/>
+  <p:sldSz cx="12192000" cy="6858000"/>
   <p:notesSz cx="6858000" cy="9144000"/>
   <p:defaultTextStyle>
     <a:defPPr>
@@ -115,6 +115,22 @@
       </a:defRPr>
     </a:lvl9pPr>
   </p:defaultTextStyle>
+  <p:extLst>
+    <p:ext uri="{EFAFB233-063F-42B5-8137-9DF3F51BA10A}">
+      <p15:sldGuideLst xmlns:p15="http://schemas.microsoft.com/office/powerpoint/2012/main">
+        <p15:guide id="1" orient="horz" pos="2160">
+          <p15:clr>
+            <a:srgbClr val="A4A3A4"/>
+          </p15:clr>
+        </p15:guide>
+        <p15:guide id="2" pos="2880">
+          <p15:clr>
+            <a:srgbClr val="A4A3A4"/>
+          </p15:clr>
+        </p15:guide>
+      </p15:sldGuideLst>
+    </p:ext>
+  </p:extLst>
 </p:presentation>
 </file>
 
@@ -156,10 +172,9 @@
           <a:lstStyle/>
           <a:p>
             <a:r>
-              <a:rPr lang="en-US" smtClean="0"/>
+              <a:rPr lang="en-US"/>
               <a:t>Click to edit Master title style</a:t>
             </a:r>
-            <a:endParaRPr lang="en-US"/>
           </a:p>
         </p:txBody>
       </p:sp>
@@ -275,10 +290,9 @@
           </a:lstStyle>
           <a:p>
             <a:r>
-              <a:rPr lang="en-US" smtClean="0"/>
+              <a:rPr lang="en-US"/>
               <a:t>Click to edit Master subtitle style</a:t>
             </a:r>
-            <a:endParaRPr lang="en-US"/>
           </a:p>
         </p:txBody>
       </p:sp>
@@ -299,7 +313,7 @@
           <a:p>
             <a:fld id="{5BCAD085-E8A6-8845-BD4E-CB4CCA059FC4}" type="datetimeFigureOut">
               <a:rPr lang="en-US" smtClean="0"/>
-              <a:t>1/27/13</a:t>
+              <a:t>10/2/2026</a:t>
             </a:fld>
             <a:endParaRPr lang="en-US"/>
           </a:p>
@@ -393,10 +407,9 @@
           <a:lstStyle/>
           <a:p>
             <a:r>
-              <a:rPr lang="en-US" smtClean="0"/>
+              <a:rPr lang="en-US"/>
               <a:t>Click to edit Master title style</a:t>
             </a:r>
-            <a:endParaRPr lang="en-US"/>
           </a:p>
         </p:txBody>
       </p:sp>
@@ -417,38 +430,37 @@
           <a:p>
             <a:pPr lvl="0"/>
             <a:r>
-              <a:rPr lang="en-US" smtClean="0"/>
+              <a:rPr lang="en-US"/>
               <a:t>Click to edit Master text styles</a:t>
             </a:r>
           </a:p>
           <a:p>
             <a:pPr lvl="1"/>
             <a:r>
-              <a:rPr lang="en-US" smtClean="0"/>
+              <a:rPr lang="en-US"/>
               <a:t>Second level</a:t>
             </a:r>
           </a:p>
           <a:p>
             <a:pPr lvl="2"/>
             <a:r>
-              <a:rPr lang="en-US" smtClean="0"/>
+              <a:rPr lang="en-US"/>
               <a:t>Third level</a:t>
             </a:r>
           </a:p>
           <a:p>
             <a:pPr lvl="3"/>
             <a:r>
-              <a:rPr lang="en-US" smtClean="0"/>
+              <a:rPr lang="en-US"/>
               <a:t>Fourth level</a:t>
             </a:r>
           </a:p>
           <a:p>
             <a:pPr lvl="4"/>
             <a:r>
-              <a:rPr lang="en-US" smtClean="0"/>
+              <a:rPr lang="en-US"/>
               <a:t>Fifth level</a:t>
             </a:r>
-            <a:endParaRPr lang="en-US"/>
           </a:p>
         </p:txBody>
       </p:sp>
@@ -469,7 +481,7 @@
           <a:p>
             <a:fld id="{5BCAD085-E8A6-8845-BD4E-CB4CCA059FC4}" type="datetimeFigureOut">
               <a:rPr lang="en-US" smtClean="0"/>
-              <a:t>1/27/13</a:t>
+              <a:t>10/2/2026</a:t>
             </a:fld>
             <a:endParaRPr lang="en-US"/>
           </a:p>
@@ -568,10 +580,9 @@
           <a:lstStyle/>
           <a:p>
             <a:r>
-              <a:rPr lang="en-US" smtClean="0"/>
+              <a:rPr lang="en-US"/>
               <a:t>Click to edit Master title style</a:t>
             </a:r>
-            <a:endParaRPr lang="en-US"/>
           </a:p>
         </p:txBody>
       </p:sp>
@@ -597,38 +608,37 @@
           <a:p>
             <a:pPr lvl="0"/>
             <a:r>
-              <a:rPr lang="en-US" smtClean="0"/>
+              <a:rPr lang="en-US"/>
               <a:t>Click to edit Master text styles</a:t>
             </a:r>
           </a:p>
           <a:p>
             <a:pPr lvl="1"/>
             <a:r>
-              <a:rPr lang="en-US" smtClean="0"/>
+              <a:rPr lang="en-US"/>
               <a:t>Second level</a:t>
             </a:r>
           </a:p>
           <a:p>
             <a:pPr lvl="2"/>
             <a:r>
-              <a:rPr lang="en-US" smtClean="0"/>
+              <a:rPr lang="en-US"/>
               <a:t>Third level</a:t>
             </a:r>
           </a:p>
           <a:p>
             <a:pPr lvl="3"/>
             <a:r>
-              <a:rPr lang="en-US" smtClean="0"/>
+              <a:rPr lang="en-US"/>
               <a:t>Fourth level</a:t>
             </a:r>
           </a:p>
           <a:p>
             <a:pPr lvl="4"/>
             <a:r>
-              <a:rPr lang="en-US" smtClean="0"/>
+              <a:rPr lang="en-US"/>
               <a:t>Fifth level</a:t>
             </a:r>
-            <a:endParaRPr lang="en-US"/>
           </a:p>
         </p:txBody>
       </p:sp>
@@ -649,7 +659,7 @@
           <a:p>
             <a:fld id="{5BCAD085-E8A6-8845-BD4E-CB4CCA059FC4}" type="datetimeFigureOut">
               <a:rPr lang="en-US" smtClean="0"/>
-              <a:t>1/27/13</a:t>
+              <a:t>10/2/2026</a:t>
             </a:fld>
             <a:endParaRPr lang="en-US"/>
           </a:p>
@@ -743,10 +753,9 @@
           <a:lstStyle/>
           <a:p>
             <a:r>
-              <a:rPr lang="en-US" smtClean="0"/>
+              <a:rPr lang="en-US"/>
               <a:t>Click to edit Master title style</a:t>
             </a:r>
-            <a:endParaRPr lang="en-US"/>
           </a:p>
         </p:txBody>
       </p:sp>
@@ -767,38 +776,37 @@
           <a:p>
             <a:pPr lvl="0"/>
             <a:r>
-              <a:rPr lang="en-US" smtClean="0"/>
+              <a:rPr lang="en-US"/>
               <a:t>Click to edit Master text styles</a:t>
             </a:r>
           </a:p>
           <a:p>
             <a:pPr lvl="1"/>
             <a:r>
-              <a:rPr lang="en-US" smtClean="0"/>
+              <a:rPr lang="en-US"/>
               <a:t>Second level</a:t>
             </a:r>
           </a:p>
           <a:p>
             <a:pPr lvl="2"/>
             <a:r>
-              <a:rPr lang="en-US" smtClean="0"/>
+              <a:rPr lang="en-US"/>
               <a:t>Third level</a:t>
             </a:r>
           </a:p>
           <a:p>
             <a:pPr lvl="3"/>
             <a:r>
-              <a:rPr lang="en-US" smtClean="0"/>
+              <a:rPr lang="en-US"/>
               <a:t>Fourth level</a:t>
             </a:r>
           </a:p>
           <a:p>
             <a:pPr lvl="4"/>
             <a:r>
-              <a:rPr lang="en-US" smtClean="0"/>
+              <a:rPr lang="en-US"/>
               <a:t>Fifth level</a:t>
             </a:r>
-            <a:endParaRPr lang="en-US"/>
           </a:p>
         </p:txBody>
       </p:sp>
@@ -819,7 +827,7 @@
           <a:p>
             <a:fld id="{5BCAD085-E8A6-8845-BD4E-CB4CCA059FC4}" type="datetimeFigureOut">
               <a:rPr lang="en-US" smtClean="0"/>
-              <a:t>1/27/13</a:t>
+              <a:t>10/2/2026</a:t>
             </a:fld>
             <a:endParaRPr lang="en-US"/>
           </a:p>
@@ -922,10 +930,9 @@
           </a:lstStyle>
           <a:p>
             <a:r>
-              <a:rPr lang="en-US" smtClean="0"/>
+              <a:rPr lang="en-US"/>
               <a:t>Click to edit Master title style</a:t>
             </a:r>
-            <a:endParaRPr lang="en-US"/>
           </a:p>
         </p:txBody>
       </p:sp>
@@ -1042,7 +1049,7 @@
           <a:p>
             <a:pPr lvl="0"/>
             <a:r>
-              <a:rPr lang="en-US" smtClean="0"/>
+              <a:rPr lang="en-US"/>
               <a:t>Click to edit Master text styles</a:t>
             </a:r>
           </a:p>
@@ -1065,7 +1072,7 @@
           <a:p>
             <a:fld id="{5BCAD085-E8A6-8845-BD4E-CB4CCA059FC4}" type="datetimeFigureOut">
               <a:rPr lang="en-US" smtClean="0"/>
-              <a:t>1/27/13</a:t>
+              <a:t>10/2/2026</a:t>
             </a:fld>
             <a:endParaRPr lang="en-US"/>
           </a:p>
@@ -1159,10 +1166,9 @@
           <a:lstStyle/>
           <a:p>
             <a:r>
-              <a:rPr lang="en-US" smtClean="0"/>
+              <a:rPr lang="en-US"/>
               <a:t>Click to edit Master title style</a:t>
             </a:r>
-            <a:endParaRPr lang="en-US"/>
           </a:p>
         </p:txBody>
       </p:sp>
@@ -1216,38 +1222,37 @@
           <a:p>
             <a:pPr lvl="0"/>
             <a:r>
-              <a:rPr lang="en-US" smtClean="0"/>
+              <a:rPr lang="en-US"/>
               <a:t>Click to edit Master text styles</a:t>
             </a:r>
           </a:p>
           <a:p>
             <a:pPr lvl="1"/>
             <a:r>
-              <a:rPr lang="en-US" smtClean="0"/>
+              <a:rPr lang="en-US"/>
               <a:t>Second level</a:t>
             </a:r>
           </a:p>
           <a:p>
             <a:pPr lvl="2"/>
             <a:r>
-              <a:rPr lang="en-US" smtClean="0"/>
+              <a:rPr lang="en-US"/>
               <a:t>Third level</a:t>
             </a:r>
           </a:p>
           <a:p>
             <a:pPr lvl="3"/>
             <a:r>
-              <a:rPr lang="en-US" smtClean="0"/>
+              <a:rPr lang="en-US"/>
               <a:t>Fourth level</a:t>
             </a:r>
           </a:p>
           <a:p>
             <a:pPr lvl="4"/>
             <a:r>
-              <a:rPr lang="en-US" smtClean="0"/>
+              <a:rPr lang="en-US"/>
               <a:t>Fifth level</a:t>
             </a:r>
-            <a:endParaRPr lang="en-US"/>
           </a:p>
         </p:txBody>
       </p:sp>
@@ -1301,38 +1306,37 @@
           <a:p>
             <a:pPr lvl="0"/>
             <a:r>
-              <a:rPr lang="en-US" smtClean="0"/>
+              <a:rPr lang="en-US"/>
               <a:t>Click to edit Master text styles</a:t>
             </a:r>
           </a:p>
           <a:p>
             <a:pPr lvl="1"/>
             <a:r>
-              <a:rPr lang="en-US" smtClean="0"/>
+              <a:rPr lang="en-US"/>
               <a:t>Second level</a:t>
             </a:r>
           </a:p>
           <a:p>
             <a:pPr lvl="2"/>
             <a:r>
-              <a:rPr lang="en-US" smtClean="0"/>
+              <a:rPr lang="en-US"/>
               <a:t>Third level</a:t>
             </a:r>
           </a:p>
           <a:p>
             <a:pPr lvl="3"/>
             <a:r>
-              <a:rPr lang="en-US" smtClean="0"/>
+              <a:rPr lang="en-US"/>
               <a:t>Fourth level</a:t>
             </a:r>
           </a:p>
           <a:p>
             <a:pPr lvl="4"/>
             <a:r>
-              <a:rPr lang="en-US" smtClean="0"/>
+              <a:rPr lang="en-US"/>
               <a:t>Fifth level</a:t>
             </a:r>
-            <a:endParaRPr lang="en-US"/>
           </a:p>
         </p:txBody>
       </p:sp>
@@ -1353,7 +1357,7 @@
           <a:p>
             <a:fld id="{5BCAD085-E8A6-8845-BD4E-CB4CCA059FC4}" type="datetimeFigureOut">
               <a:rPr lang="en-US" smtClean="0"/>
-              <a:t>1/27/13</a:t>
+              <a:t>10/2/2026</a:t>
             </a:fld>
             <a:endParaRPr lang="en-US"/>
           </a:p>
@@ -1451,10 +1455,9 @@
           </a:lstStyle>
           <a:p>
             <a:r>
-              <a:rPr lang="en-US" smtClean="0"/>
+              <a:rPr lang="en-US"/>
               <a:t>Click to edit Master title style</a:t>
             </a:r>
-            <a:endParaRPr lang="en-US"/>
           </a:p>
         </p:txBody>
       </p:sp>
@@ -1517,7 +1520,7 @@
           <a:p>
             <a:pPr lvl="0"/>
             <a:r>
-              <a:rPr lang="en-US" smtClean="0"/>
+              <a:rPr lang="en-US"/>
               <a:t>Click to edit Master text styles</a:t>
             </a:r>
           </a:p>
@@ -1573,38 +1576,37 @@
           <a:p>
             <a:pPr lvl="0"/>
             <a:r>
-              <a:rPr lang="en-US" smtClean="0"/>
+              <a:rPr lang="en-US"/>
               <a:t>Click to edit Master text styles</a:t>
             </a:r>
           </a:p>
           <a:p>
             <a:pPr lvl="1"/>
             <a:r>
-              <a:rPr lang="en-US" smtClean="0"/>
+              <a:rPr lang="en-US"/>
               <a:t>Second level</a:t>
             </a:r>
           </a:p>
           <a:p>
             <a:pPr lvl="2"/>
             <a:r>
-              <a:rPr lang="en-US" smtClean="0"/>
+              <a:rPr lang="en-US"/>
               <a:t>Third level</a:t>
             </a:r>
           </a:p>
           <a:p>
             <a:pPr lvl="3"/>
             <a:r>
-              <a:rPr lang="en-US" smtClean="0"/>
+              <a:rPr lang="en-US"/>
               <a:t>Fourth level</a:t>
             </a:r>
           </a:p>
           <a:p>
             <a:pPr lvl="4"/>
             <a:r>
-              <a:rPr lang="en-US" smtClean="0"/>
+              <a:rPr lang="en-US"/>
               <a:t>Fifth level</a:t>
             </a:r>
-            <a:endParaRPr lang="en-US"/>
           </a:p>
         </p:txBody>
       </p:sp>
@@ -1667,7 +1669,7 @@
           <a:p>
             <a:pPr lvl="0"/>
             <a:r>
-              <a:rPr lang="en-US" smtClean="0"/>
+              <a:rPr lang="en-US"/>
               <a:t>Click to edit Master text styles</a:t>
             </a:r>
           </a:p>
@@ -1723,38 +1725,37 @@
           <a:p>
             <a:pPr lvl="0"/>
             <a:r>
-              <a:rPr lang="en-US" smtClean="0"/>
+              <a:rPr lang="en-US"/>
               <a:t>Click to edit Master text styles</a:t>
             </a:r>
           </a:p>
           <a:p>
             <a:pPr lvl="1"/>
             <a:r>
-              <a:rPr lang="en-US" smtClean="0"/>
+              <a:rPr lang="en-US"/>
               <a:t>Second level</a:t>
             </a:r>
           </a:p>
           <a:p>
             <a:pPr lvl="2"/>
             <a:r>
-              <a:rPr lang="en-US" smtClean="0"/>
+              <a:rPr lang="en-US"/>
               <a:t>Third level</a:t>
             </a:r>
           </a:p>
           <a:p>
             <a:pPr lvl="3"/>
             <a:r>
-              <a:rPr lang="en-US" smtClean="0"/>
+              <a:rPr lang="en-US"/>
               <a:t>Fourth level</a:t>
             </a:r>
           </a:p>
           <a:p>
             <a:pPr lvl="4"/>
             <a:r>
-              <a:rPr lang="en-US" smtClean="0"/>
+              <a:rPr lang="en-US"/>
               <a:t>Fifth level</a:t>
             </a:r>
-            <a:endParaRPr lang="en-US"/>
           </a:p>
         </p:txBody>
       </p:sp>
@@ -1775,7 +1776,7 @@
           <a:p>
             <a:fld id="{5BCAD085-E8A6-8845-BD4E-CB4CCA059FC4}" type="datetimeFigureOut">
               <a:rPr lang="en-US" smtClean="0"/>
-              <a:t>1/27/13</a:t>
+              <a:t>10/2/2026</a:t>
             </a:fld>
             <a:endParaRPr lang="en-US"/>
           </a:p>
@@ -1869,10 +1870,9 @@
           <a:lstStyle/>
           <a:p>
             <a:r>
-              <a:rPr lang="en-US" smtClean="0"/>
+              <a:rPr lang="en-US"/>
               <a:t>Click to edit Master title style</a:t>
             </a:r>
-            <a:endParaRPr lang="en-US"/>
           </a:p>
         </p:txBody>
       </p:sp>
@@ -1893,7 +1893,7 @@
           <a:p>
             <a:fld id="{5BCAD085-E8A6-8845-BD4E-CB4CCA059FC4}" type="datetimeFigureOut">
               <a:rPr lang="en-US" smtClean="0"/>
-              <a:t>1/27/13</a:t>
+              <a:t>10/2/2026</a:t>
             </a:fld>
             <a:endParaRPr lang="en-US"/>
           </a:p>
@@ -1988,7 +1988,7 @@
           <a:p>
             <a:fld id="{5BCAD085-E8A6-8845-BD4E-CB4CCA059FC4}" type="datetimeFigureOut">
               <a:rPr lang="en-US" smtClean="0"/>
-              <a:t>1/27/13</a:t>
+              <a:t>10/2/2026</a:t>
             </a:fld>
             <a:endParaRPr lang="en-US"/>
           </a:p>
@@ -2091,10 +2091,9 @@
           </a:lstStyle>
           <a:p>
             <a:r>
-              <a:rPr lang="en-US" smtClean="0"/>
+              <a:rPr lang="en-US"/>
               <a:t>Click to edit Master title style</a:t>
             </a:r>
-            <a:endParaRPr lang="en-US"/>
           </a:p>
         </p:txBody>
       </p:sp>
@@ -2148,38 +2147,37 @@
           <a:p>
             <a:pPr lvl="0"/>
             <a:r>
-              <a:rPr lang="en-US" smtClean="0"/>
+              <a:rPr lang="en-US"/>
               <a:t>Click to edit Master text styles</a:t>
             </a:r>
           </a:p>
           <a:p>
             <a:pPr lvl="1"/>
             <a:r>
-              <a:rPr lang="en-US" smtClean="0"/>
+              <a:rPr lang="en-US"/>
               <a:t>Second level</a:t>
             </a:r>
           </a:p>
           <a:p>
             <a:pPr lvl="2"/>
             <a:r>
-              <a:rPr lang="en-US" smtClean="0"/>
+              <a:rPr lang="en-US"/>
               <a:t>Third level</a:t>
             </a:r>
           </a:p>
           <a:p>
             <a:pPr lvl="3"/>
             <a:r>
-              <a:rPr lang="en-US" smtClean="0"/>
+              <a:rPr lang="en-US"/>
               <a:t>Fourth level</a:t>
             </a:r>
           </a:p>
           <a:p>
             <a:pPr lvl="4"/>
             <a:r>
-              <a:rPr lang="en-US" smtClean="0"/>
+              <a:rPr lang="en-US"/>
               <a:t>Fifth level</a:t>
             </a:r>
-            <a:endParaRPr lang="en-US"/>
           </a:p>
         </p:txBody>
       </p:sp>
@@ -2242,7 +2240,7 @@
           <a:p>
             <a:pPr lvl="0"/>
             <a:r>
-              <a:rPr lang="en-US" smtClean="0"/>
+              <a:rPr lang="en-US"/>
               <a:t>Click to edit Master text styles</a:t>
             </a:r>
           </a:p>
@@ -2265,7 +2263,7 @@
           <a:p>
             <a:fld id="{5BCAD085-E8A6-8845-BD4E-CB4CCA059FC4}" type="datetimeFigureOut">
               <a:rPr lang="en-US" smtClean="0"/>
-              <a:t>1/27/13</a:t>
+              <a:t>10/2/2026</a:t>
             </a:fld>
             <a:endParaRPr lang="en-US"/>
           </a:p>
@@ -2368,10 +2366,9 @@
           </a:lstStyle>
           <a:p>
             <a:r>
-              <a:rPr lang="en-US" smtClean="0"/>
+              <a:rPr lang="en-US"/>
               <a:t>Click to edit Master title style</a:t>
             </a:r>
-            <a:endParaRPr lang="en-US"/>
           </a:p>
         </p:txBody>
       </p:sp>
@@ -2495,7 +2492,7 @@
           <a:p>
             <a:pPr lvl="0"/>
             <a:r>
-              <a:rPr lang="en-US" smtClean="0"/>
+              <a:rPr lang="en-US"/>
               <a:t>Click to edit Master text styles</a:t>
             </a:r>
           </a:p>
@@ -2518,7 +2515,7 @@
           <a:p>
             <a:fld id="{5BCAD085-E8A6-8845-BD4E-CB4CCA059FC4}" type="datetimeFigureOut">
               <a:rPr lang="en-US" smtClean="0"/>
-              <a:t>1/27/13</a:t>
+              <a:t>10/2/2026</a:t>
             </a:fld>
             <a:endParaRPr lang="en-US"/>
           </a:p>
@@ -2627,10 +2624,9 @@
           <a:lstStyle/>
           <a:p>
             <a:r>
-              <a:rPr lang="en-US" smtClean="0"/>
+              <a:rPr lang="en-US"/>
               <a:t>Click to edit Master title style</a:t>
             </a:r>
-            <a:endParaRPr lang="en-US"/>
           </a:p>
         </p:txBody>
       </p:sp>
@@ -2661,38 +2657,37 @@
           <a:p>
             <a:pPr lvl="0"/>
             <a:r>
-              <a:rPr lang="en-US" smtClean="0"/>
+              <a:rPr lang="en-US"/>
               <a:t>Click to edit Master text styles</a:t>
             </a:r>
           </a:p>
           <a:p>
             <a:pPr lvl="1"/>
             <a:r>
-              <a:rPr lang="en-US" smtClean="0"/>
+              <a:rPr lang="en-US"/>
               <a:t>Second level</a:t>
             </a:r>
           </a:p>
           <a:p>
             <a:pPr lvl="2"/>
             <a:r>
-              <a:rPr lang="en-US" smtClean="0"/>
+              <a:rPr lang="en-US"/>
               <a:t>Third level</a:t>
             </a:r>
           </a:p>
           <a:p>
             <a:pPr lvl="3"/>
             <a:r>
-              <a:rPr lang="en-US" smtClean="0"/>
+              <a:rPr lang="en-US"/>
               <a:t>Fourth level</a:t>
             </a:r>
           </a:p>
           <a:p>
             <a:pPr lvl="4"/>
             <a:r>
-              <a:rPr lang="en-US" smtClean="0"/>
+              <a:rPr lang="en-US"/>
               <a:t>Fifth level</a:t>
             </a:r>
-            <a:endParaRPr lang="en-US"/>
           </a:p>
         </p:txBody>
       </p:sp>
@@ -2731,7 +2726,7 @@
           <a:p>
             <a:fld id="{5BCAD085-E8A6-8845-BD4E-CB4CCA059FC4}" type="datetimeFigureOut">
               <a:rPr lang="en-US" smtClean="0"/>
-              <a:t>1/27/13</a:t>
+              <a:t>10/2/2026</a:t>
             </a:fld>
             <a:endParaRPr lang="en-US"/>
           </a:p>
@@ -3090,7 +3085,7 @@
 </file>
 
 <file path=ppt/slides/slide1.xml><?xml version="1.0" encoding="utf-8"?>
-<p:sld xmlns:a="http://schemas.openxmlformats.org/drawingml/2006/main" xmlns:p="http://schemas.openxmlformats.org/presentationml/2006/main" xmlns:r="http://schemas.openxmlformats.org/officeDocument/2006/relationships">
+<p:sld xmlns:a="http://schemas.openxmlformats.org/drawingml/2006/main" xmlns:r="http://schemas.openxmlformats.org/officeDocument/2006/relationships" xmlns:p="http://schemas.openxmlformats.org/presentationml/2006/main">
   <p:cSld>
     <p:spTree>
       <p:nvGrpSpPr>
@@ -3098,7 +3093,14 @@
         <p:cNvGrpSpPr/>
         <p:nvPr/>
       </p:nvGrpSpPr>
-      <p:grpSpPr/>
+      <p:grpSpPr>
+        <a:xfrm>
+          <a:off x="0" y="0"/>
+          <a:ext cx="0" cy="0"/>
+          <a:chOff x="0" y="0"/>
+          <a:chExt cx="0" cy="0"/>
+        </a:xfrm>
+      </p:grpSpPr>
       <p:sp>
         <p:nvSpPr>
           <p:cNvPr id="2" name="Rectangle 1"/>
@@ -3140,6 +3142,7 @@
           <a:lstStyle/>
           <a:p>
             <a:pPr algn="ctr"/>
+            <a:endParaRPr/>
           </a:p>
         </p:txBody>
       </p:sp>
@@ -3184,6 +3187,7 @@
           <a:lstStyle/>
           <a:p>
             <a:pPr algn="ctr"/>
+            <a:endParaRPr/>
           </a:p>
         </p:txBody>
       </p:sp>
@@ -3422,7 +3426,7 @@
 </file>
 
 <file path=ppt/slides/slide10.xml><?xml version="1.0" encoding="utf-8"?>
-<p:sld xmlns:a="http://schemas.openxmlformats.org/drawingml/2006/main" xmlns:p="http://schemas.openxmlformats.org/presentationml/2006/main" xmlns:r="http://schemas.openxmlformats.org/officeDocument/2006/relationships">
+<p:sld xmlns:a="http://schemas.openxmlformats.org/drawingml/2006/main" xmlns:r="http://schemas.openxmlformats.org/officeDocument/2006/relationships" xmlns:p="http://schemas.openxmlformats.org/presentationml/2006/main">
   <p:cSld>
     <p:spTree>
       <p:nvGrpSpPr>
@@ -3430,7 +3434,14 @@
         <p:cNvGrpSpPr/>
         <p:nvPr/>
       </p:nvGrpSpPr>
-      <p:grpSpPr/>
+      <p:grpSpPr>
+        <a:xfrm>
+          <a:off x="0" y="0"/>
+          <a:ext cx="0" cy="0"/>
+          <a:chOff x="0" y="0"/>
+          <a:chExt cx="0" cy="0"/>
+        </a:xfrm>
+      </p:grpSpPr>
       <p:sp>
         <p:nvSpPr>
           <p:cNvPr id="2" name="Rectangle 1"/>
@@ -3472,6 +3483,7 @@
           <a:lstStyle/>
           <a:p>
             <a:pPr algn="ctr"/>
+            <a:endParaRPr/>
           </a:p>
         </p:txBody>
       </p:sp>
@@ -3516,6 +3528,7 @@
           <a:lstStyle/>
           <a:p>
             <a:pPr algn="ctr"/>
+            <a:endParaRPr/>
           </a:p>
         </p:txBody>
       </p:sp>
@@ -3630,6 +3643,7 @@
           <a:lstStyle/>
           <a:p>
             <a:pPr algn="ctr"/>
+            <a:endParaRPr/>
           </a:p>
         </p:txBody>
       </p:sp>
@@ -3775,7 +3789,7 @@
 </file>
 
 <file path=ppt/slides/slide11.xml><?xml version="1.0" encoding="utf-8"?>
-<p:sld xmlns:a="http://schemas.openxmlformats.org/drawingml/2006/main" xmlns:p="http://schemas.openxmlformats.org/presentationml/2006/main" xmlns:r="http://schemas.openxmlformats.org/officeDocument/2006/relationships">
+<p:sld xmlns:a="http://schemas.openxmlformats.org/drawingml/2006/main" xmlns:r="http://schemas.openxmlformats.org/officeDocument/2006/relationships" xmlns:p="http://schemas.openxmlformats.org/presentationml/2006/main">
   <p:cSld>
     <p:spTree>
       <p:nvGrpSpPr>
@@ -3783,7 +3797,14 @@
         <p:cNvGrpSpPr/>
         <p:nvPr/>
       </p:nvGrpSpPr>
-      <p:grpSpPr/>
+      <p:grpSpPr>
+        <a:xfrm>
+          <a:off x="0" y="0"/>
+          <a:ext cx="0" cy="0"/>
+          <a:chOff x="0" y="0"/>
+          <a:chExt cx="0" cy="0"/>
+        </a:xfrm>
+      </p:grpSpPr>
       <p:sp>
         <p:nvSpPr>
           <p:cNvPr id="2" name="Rectangle 1"/>
@@ -3825,6 +3846,7 @@
           <a:lstStyle/>
           <a:p>
             <a:pPr algn="ctr"/>
+            <a:endParaRPr/>
           </a:p>
         </p:txBody>
       </p:sp>
@@ -3869,6 +3891,7 @@
           <a:lstStyle/>
           <a:p>
             <a:pPr algn="ctr"/>
+            <a:endParaRPr/>
           </a:p>
         </p:txBody>
       </p:sp>
@@ -4158,7 +4181,7 @@
 </file>
 
 <file path=ppt/slides/slide12.xml><?xml version="1.0" encoding="utf-8"?>
-<p:sld xmlns:a="http://schemas.openxmlformats.org/drawingml/2006/main" xmlns:p="http://schemas.openxmlformats.org/presentationml/2006/main" xmlns:r="http://schemas.openxmlformats.org/officeDocument/2006/relationships">
+<p:sld xmlns:a="http://schemas.openxmlformats.org/drawingml/2006/main" xmlns:r="http://schemas.openxmlformats.org/officeDocument/2006/relationships" xmlns:p="http://schemas.openxmlformats.org/presentationml/2006/main">
   <p:cSld>
     <p:spTree>
       <p:nvGrpSpPr>
@@ -4166,7 +4189,14 @@
         <p:cNvGrpSpPr/>
         <p:nvPr/>
       </p:nvGrpSpPr>
-      <p:grpSpPr/>
+      <p:grpSpPr>
+        <a:xfrm>
+          <a:off x="0" y="0"/>
+          <a:ext cx="0" cy="0"/>
+          <a:chOff x="0" y="0"/>
+          <a:chExt cx="0" cy="0"/>
+        </a:xfrm>
+      </p:grpSpPr>
       <p:sp>
         <p:nvSpPr>
           <p:cNvPr id="2" name="Rectangle 1"/>
@@ -4208,6 +4238,7 @@
           <a:lstStyle/>
           <a:p>
             <a:pPr algn="ctr"/>
+            <a:endParaRPr/>
           </a:p>
         </p:txBody>
       </p:sp>
@@ -4252,6 +4283,7 @@
           <a:lstStyle/>
           <a:p>
             <a:pPr algn="ctr"/>
+            <a:endParaRPr/>
           </a:p>
         </p:txBody>
       </p:sp>
@@ -4511,7 +4543,7 @@
 </file>
 
 <file path=ppt/slides/slide2.xml><?xml version="1.0" encoding="utf-8"?>
-<p:sld xmlns:a="http://schemas.openxmlformats.org/drawingml/2006/main" xmlns:p="http://schemas.openxmlformats.org/presentationml/2006/main" xmlns:r="http://schemas.openxmlformats.org/officeDocument/2006/relationships">
+<p:sld xmlns:a="http://schemas.openxmlformats.org/drawingml/2006/main" xmlns:r="http://schemas.openxmlformats.org/officeDocument/2006/relationships" xmlns:p="http://schemas.openxmlformats.org/presentationml/2006/main">
   <p:cSld>
     <p:spTree>
       <p:nvGrpSpPr>
@@ -4519,7 +4551,14 @@
         <p:cNvGrpSpPr/>
         <p:nvPr/>
       </p:nvGrpSpPr>
-      <p:grpSpPr/>
+      <p:grpSpPr>
+        <a:xfrm>
+          <a:off x="0" y="0"/>
+          <a:ext cx="0" cy="0"/>
+          <a:chOff x="0" y="0"/>
+          <a:chExt cx="0" cy="0"/>
+        </a:xfrm>
+      </p:grpSpPr>
       <p:sp>
         <p:nvSpPr>
           <p:cNvPr id="2" name="Rectangle 1"/>
@@ -4561,6 +4600,7 @@
           <a:lstStyle/>
           <a:p>
             <a:pPr algn="ctr"/>
+            <a:endParaRPr/>
           </a:p>
         </p:txBody>
       </p:sp>
@@ -4605,6 +4645,7 @@
           <a:lstStyle/>
           <a:p>
             <a:pPr algn="ctr"/>
+            <a:endParaRPr/>
           </a:p>
         </p:txBody>
       </p:sp>
@@ -4839,7 +4880,7 @@
 </file>
 
 <file path=ppt/slides/slide3.xml><?xml version="1.0" encoding="utf-8"?>
-<p:sld xmlns:a="http://schemas.openxmlformats.org/drawingml/2006/main" xmlns:p="http://schemas.openxmlformats.org/presentationml/2006/main" xmlns:r="http://schemas.openxmlformats.org/officeDocument/2006/relationships">
+<p:sld xmlns:a="http://schemas.openxmlformats.org/drawingml/2006/main" xmlns:r="http://schemas.openxmlformats.org/officeDocument/2006/relationships" xmlns:p="http://schemas.openxmlformats.org/presentationml/2006/main">
   <p:cSld>
     <p:spTree>
       <p:nvGrpSpPr>
@@ -4847,7 +4888,14 @@
         <p:cNvGrpSpPr/>
         <p:nvPr/>
       </p:nvGrpSpPr>
-      <p:grpSpPr/>
+      <p:grpSpPr>
+        <a:xfrm>
+          <a:off x="0" y="0"/>
+          <a:ext cx="0" cy="0"/>
+          <a:chOff x="0" y="0"/>
+          <a:chExt cx="0" cy="0"/>
+        </a:xfrm>
+      </p:grpSpPr>
       <p:sp>
         <p:nvSpPr>
           <p:cNvPr id="2" name="Rectangle 1"/>
@@ -4889,6 +4937,7 @@
           <a:lstStyle/>
           <a:p>
             <a:pPr algn="ctr"/>
+            <a:endParaRPr/>
           </a:p>
         </p:txBody>
       </p:sp>
@@ -4933,6 +4982,7 @@
           <a:lstStyle/>
           <a:p>
             <a:pPr algn="ctr"/>
+            <a:endParaRPr/>
           </a:p>
         </p:txBody>
       </p:sp>
@@ -5082,7 +5132,7 @@
           </a:fontRef>
         </p:style>
         <p:txBody>
-          <a:bodyPr rtlCol="0" anchor="ctr" wrap="square" lIns="182880" tIns="91440"/>
+          <a:bodyPr wrap="square" lIns="182880" tIns="91440" rtlCol="0" anchor="ctr"/>
           <a:lstStyle/>
           <a:p>
             <a:pPr algn="ctr"/>
@@ -5153,7 +5203,7 @@
           </a:fontRef>
         </p:style>
         <p:txBody>
-          <a:bodyPr rtlCol="0" anchor="ctr" wrap="square" lIns="182880" tIns="91440"/>
+          <a:bodyPr wrap="square" lIns="182880" tIns="91440" rtlCol="0" anchor="ctr"/>
           <a:lstStyle/>
           <a:p>
             <a:pPr algn="ctr"/>
@@ -5224,7 +5274,7 @@
           </a:fontRef>
         </p:style>
         <p:txBody>
-          <a:bodyPr rtlCol="0" anchor="ctr" wrap="square" lIns="182880" tIns="91440"/>
+          <a:bodyPr wrap="square" lIns="182880" tIns="91440" rtlCol="0" anchor="ctr"/>
           <a:lstStyle/>
           <a:p>
             <a:pPr algn="ctr"/>
@@ -5339,7 +5389,7 @@
 </file>
 
 <file path=ppt/slides/slide4.xml><?xml version="1.0" encoding="utf-8"?>
-<p:sld xmlns:a="http://schemas.openxmlformats.org/drawingml/2006/main" xmlns:p="http://schemas.openxmlformats.org/presentationml/2006/main" xmlns:r="http://schemas.openxmlformats.org/officeDocument/2006/relationships">
+<p:sld xmlns:a="http://schemas.openxmlformats.org/drawingml/2006/main" xmlns:r="http://schemas.openxmlformats.org/officeDocument/2006/relationships" xmlns:p="http://schemas.openxmlformats.org/presentationml/2006/main">
   <p:cSld>
     <p:spTree>
       <p:nvGrpSpPr>
@@ -5347,7 +5397,14 @@
         <p:cNvGrpSpPr/>
         <p:nvPr/>
       </p:nvGrpSpPr>
-      <p:grpSpPr/>
+      <p:grpSpPr>
+        <a:xfrm>
+          <a:off x="0" y="0"/>
+          <a:ext cx="0" cy="0"/>
+          <a:chOff x="0" y="0"/>
+          <a:chExt cx="0" cy="0"/>
+        </a:xfrm>
+      </p:grpSpPr>
       <p:sp>
         <p:nvSpPr>
           <p:cNvPr id="2" name="Rectangle 1"/>
@@ -5389,6 +5446,7 @@
           <a:lstStyle/>
           <a:p>
             <a:pPr algn="ctr"/>
+            <a:endParaRPr/>
           </a:p>
         </p:txBody>
       </p:sp>
@@ -5433,6 +5491,7 @@
           <a:lstStyle/>
           <a:p>
             <a:pPr algn="ctr"/>
+            <a:endParaRPr/>
           </a:p>
         </p:txBody>
       </p:sp>
@@ -5546,7 +5605,7 @@
           </a:fontRef>
         </p:style>
         <p:txBody>
-          <a:bodyPr rtlCol="0" anchor="ctr" wrap="square" lIns="201168" rIns="201168" tIns="164592" bIns="164592"/>
+          <a:bodyPr wrap="square" lIns="201168" tIns="164592" rIns="201168" bIns="164592" rtlCol="0" anchor="ctr"/>
           <a:lstStyle/>
           <a:p>
             <a:pPr algn="ctr"/>
@@ -5657,7 +5716,7 @@
           </a:fontRef>
         </p:style>
         <p:txBody>
-          <a:bodyPr rtlCol="0" anchor="ctr" wrap="square" lIns="201168" rIns="201168" tIns="164592" bIns="164592"/>
+          <a:bodyPr wrap="square" lIns="201168" tIns="164592" rIns="201168" bIns="164592" rtlCol="0" anchor="ctr"/>
           <a:lstStyle/>
           <a:p>
             <a:pPr algn="ctr"/>
@@ -5775,7 +5834,7 @@
 </file>
 
 <file path=ppt/slides/slide5.xml><?xml version="1.0" encoding="utf-8"?>
-<p:sld xmlns:a="http://schemas.openxmlformats.org/drawingml/2006/main" xmlns:p="http://schemas.openxmlformats.org/presentationml/2006/main" xmlns:r="http://schemas.openxmlformats.org/officeDocument/2006/relationships">
+<p:sld xmlns:a="http://schemas.openxmlformats.org/drawingml/2006/main" xmlns:r="http://schemas.openxmlformats.org/officeDocument/2006/relationships" xmlns:p="http://schemas.openxmlformats.org/presentationml/2006/main">
   <p:cSld>
     <p:spTree>
       <p:nvGrpSpPr>
@@ -5783,7 +5842,14 @@
         <p:cNvGrpSpPr/>
         <p:nvPr/>
       </p:nvGrpSpPr>
-      <p:grpSpPr/>
+      <p:grpSpPr>
+        <a:xfrm>
+          <a:off x="0" y="0"/>
+          <a:ext cx="0" cy="0"/>
+          <a:chOff x="0" y="0"/>
+          <a:chExt cx="0" cy="0"/>
+        </a:xfrm>
+      </p:grpSpPr>
       <p:sp>
         <p:nvSpPr>
           <p:cNvPr id="2" name="Rectangle 1"/>
@@ -5825,6 +5891,7 @@
           <a:lstStyle/>
           <a:p>
             <a:pPr algn="ctr"/>
+            <a:endParaRPr/>
           </a:p>
         </p:txBody>
       </p:sp>
@@ -5869,6 +5936,7 @@
           <a:lstStyle/>
           <a:p>
             <a:pPr algn="ctr"/>
+            <a:endParaRPr/>
           </a:p>
         </p:txBody>
       </p:sp>
@@ -6020,7 +6088,7 @@
           </a:fontRef>
         </p:style>
         <p:txBody>
-          <a:bodyPr rtlCol="0" anchor="ctr" wrap="square" lIns="201168" rIns="201168" tIns="164592" bIns="164592"/>
+          <a:bodyPr wrap="square" lIns="201168" tIns="164592" rIns="201168" bIns="164592" rtlCol="0" anchor="ctr"/>
           <a:lstStyle/>
           <a:p>
             <a:pPr algn="ctr"/>
@@ -6099,7 +6167,7 @@
 </file>
 
 <file path=ppt/slides/slide6.xml><?xml version="1.0" encoding="utf-8"?>
-<p:sld xmlns:a="http://schemas.openxmlformats.org/drawingml/2006/main" xmlns:p="http://schemas.openxmlformats.org/presentationml/2006/main" xmlns:r="http://schemas.openxmlformats.org/officeDocument/2006/relationships">
+<p:sld xmlns:a="http://schemas.openxmlformats.org/drawingml/2006/main" xmlns:r="http://schemas.openxmlformats.org/officeDocument/2006/relationships" xmlns:p="http://schemas.openxmlformats.org/presentationml/2006/main">
   <p:cSld>
     <p:spTree>
       <p:nvGrpSpPr>
@@ -6107,7 +6175,14 @@
         <p:cNvGrpSpPr/>
         <p:nvPr/>
       </p:nvGrpSpPr>
-      <p:grpSpPr/>
+      <p:grpSpPr>
+        <a:xfrm>
+          <a:off x="0" y="0"/>
+          <a:ext cx="0" cy="0"/>
+          <a:chOff x="0" y="0"/>
+          <a:chExt cx="0" cy="0"/>
+        </a:xfrm>
+      </p:grpSpPr>
       <p:sp>
         <p:nvSpPr>
           <p:cNvPr id="2" name="Rectangle 1"/>
@@ -6149,6 +6224,7 @@
           <a:lstStyle/>
           <a:p>
             <a:pPr algn="ctr"/>
+            <a:endParaRPr/>
           </a:p>
         </p:txBody>
       </p:sp>
@@ -6193,6 +6269,7 @@
           <a:lstStyle/>
           <a:p>
             <a:pPr algn="ctr"/>
+            <a:endParaRPr/>
           </a:p>
         </p:txBody>
       </p:sp>
@@ -6303,7 +6380,7 @@
           </a:fontRef>
         </p:style>
         <p:txBody>
-          <a:bodyPr rtlCol="0" anchor="ctr" wrap="square" lIns="73152" rIns="73152"/>
+          <a:bodyPr wrap="square" lIns="73152" rIns="73152" rtlCol="0" anchor="ctr"/>
           <a:lstStyle/>
           <a:p>
             <a:pPr algn="ctr"/>
@@ -6378,7 +6455,7 @@
           </a:fontRef>
         </p:style>
         <p:txBody>
-          <a:bodyPr rtlCol="0" anchor="ctr" wrap="square" lIns="73152" rIns="73152"/>
+          <a:bodyPr wrap="square" lIns="73152" rIns="73152" rtlCol="0" anchor="ctr"/>
           <a:lstStyle/>
           <a:p>
             <a:pPr algn="ctr"/>
@@ -6453,7 +6530,7 @@
           </a:fontRef>
         </p:style>
         <p:txBody>
-          <a:bodyPr rtlCol="0" anchor="ctr" wrap="square" lIns="73152" rIns="73152"/>
+          <a:bodyPr wrap="square" lIns="73152" rIns="73152" rtlCol="0" anchor="ctr"/>
           <a:lstStyle/>
           <a:p>
             <a:pPr algn="ctr"/>
@@ -6527,7 +6604,7 @@
           </a:fontRef>
         </p:style>
         <p:txBody>
-          <a:bodyPr rtlCol="0" anchor="ctr" wrap="square" lIns="73152" rIns="73152"/>
+          <a:bodyPr wrap="square" lIns="73152" rIns="73152" rtlCol="0" anchor="ctr"/>
           <a:lstStyle/>
           <a:p>
             <a:pPr algn="ctr"/>
@@ -6602,7 +6679,7 @@
           </a:fontRef>
         </p:style>
         <p:txBody>
-          <a:bodyPr rtlCol="0" anchor="ctr" wrap="square" lIns="73152" rIns="73152"/>
+          <a:bodyPr wrap="square" lIns="73152" rIns="73152" rtlCol="0" anchor="ctr"/>
           <a:lstStyle/>
           <a:p>
             <a:pPr algn="ctr"/>
@@ -6677,7 +6754,7 @@
           </a:fontRef>
         </p:style>
         <p:txBody>
-          <a:bodyPr rtlCol="0" anchor="ctr" wrap="square" lIns="73152" rIns="73152"/>
+          <a:bodyPr wrap="square" lIns="73152" rIns="73152" rtlCol="0" anchor="ctr"/>
           <a:lstStyle/>
           <a:p>
             <a:pPr algn="ctr"/>
@@ -6752,7 +6829,7 @@
           </a:fontRef>
         </p:style>
         <p:txBody>
-          <a:bodyPr rtlCol="0" anchor="ctr" wrap="square" lIns="73152" rIns="73152"/>
+          <a:bodyPr wrap="square" lIns="73152" rIns="73152" rtlCol="0" anchor="ctr"/>
           <a:lstStyle/>
           <a:p>
             <a:pPr algn="ctr"/>
@@ -6871,7 +6948,7 @@
 </file>
 
 <file path=ppt/slides/slide7.xml><?xml version="1.0" encoding="utf-8"?>
-<p:sld xmlns:a="http://schemas.openxmlformats.org/drawingml/2006/main" xmlns:p="http://schemas.openxmlformats.org/presentationml/2006/main" xmlns:r="http://schemas.openxmlformats.org/officeDocument/2006/relationships">
+<p:sld xmlns:a="http://schemas.openxmlformats.org/drawingml/2006/main" xmlns:r="http://schemas.openxmlformats.org/officeDocument/2006/relationships" xmlns:p="http://schemas.openxmlformats.org/presentationml/2006/main">
   <p:cSld>
     <p:spTree>
       <p:nvGrpSpPr>
@@ -6879,7 +6956,14 @@
         <p:cNvGrpSpPr/>
         <p:nvPr/>
       </p:nvGrpSpPr>
-      <p:grpSpPr/>
+      <p:grpSpPr>
+        <a:xfrm>
+          <a:off x="0" y="0"/>
+          <a:ext cx="0" cy="0"/>
+          <a:chOff x="0" y="0"/>
+          <a:chExt cx="0" cy="0"/>
+        </a:xfrm>
+      </p:grpSpPr>
       <p:sp>
         <p:nvSpPr>
           <p:cNvPr id="2" name="Rectangle 1"/>
@@ -6921,6 +7005,7 @@
           <a:lstStyle/>
           <a:p>
             <a:pPr algn="ctr"/>
+            <a:endParaRPr/>
           </a:p>
         </p:txBody>
       </p:sp>
@@ -6965,6 +7050,7 @@
           <a:lstStyle/>
           <a:p>
             <a:pPr algn="ctr"/>
+            <a:endParaRPr/>
           </a:p>
         </p:txBody>
       </p:sp>
@@ -7116,7 +7202,7 @@
           </a:fontRef>
         </p:style>
         <p:txBody>
-          <a:bodyPr rtlCol="0" anchor="ctr" wrap="square" lIns="201168" rIns="201168" tIns="164592" bIns="164592"/>
+          <a:bodyPr wrap="square" lIns="201168" tIns="164592" rIns="201168" bIns="164592" rtlCol="0" anchor="ctr"/>
           <a:lstStyle/>
           <a:p>
             <a:pPr algn="ctr"/>
@@ -7192,7 +7278,7 @@
           </a:fontRef>
         </p:style>
         <p:txBody>
-          <a:bodyPr rtlCol="0" anchor="ctr" wrap="square" lIns="201168" rIns="201168" tIns="164592" bIns="164592"/>
+          <a:bodyPr wrap="square" lIns="201168" tIns="164592" rIns="201168" bIns="164592" rtlCol="0" anchor="ctr"/>
           <a:lstStyle/>
           <a:p>
             <a:pPr algn="ctr"/>
@@ -7271,7 +7357,7 @@
 </file>
 
 <file path=ppt/slides/slide8.xml><?xml version="1.0" encoding="utf-8"?>
-<p:sld xmlns:a="http://schemas.openxmlformats.org/drawingml/2006/main" xmlns:p="http://schemas.openxmlformats.org/presentationml/2006/main" xmlns:r="http://schemas.openxmlformats.org/officeDocument/2006/relationships">
+<p:sld xmlns:a="http://schemas.openxmlformats.org/drawingml/2006/main" xmlns:r="http://schemas.openxmlformats.org/officeDocument/2006/relationships" xmlns:p="http://schemas.openxmlformats.org/presentationml/2006/main">
   <p:cSld>
     <p:spTree>
       <p:nvGrpSpPr>
@@ -7279,7 +7365,14 @@
         <p:cNvGrpSpPr/>
         <p:nvPr/>
       </p:nvGrpSpPr>
-      <p:grpSpPr/>
+      <p:grpSpPr>
+        <a:xfrm>
+          <a:off x="0" y="0"/>
+          <a:ext cx="0" cy="0"/>
+          <a:chOff x="0" y="0"/>
+          <a:chExt cx="0" cy="0"/>
+        </a:xfrm>
+      </p:grpSpPr>
       <p:sp>
         <p:nvSpPr>
           <p:cNvPr id="2" name="Rectangle 1"/>
@@ -7321,6 +7414,7 @@
           <a:lstStyle/>
           <a:p>
             <a:pPr algn="ctr"/>
+            <a:endParaRPr/>
           </a:p>
         </p:txBody>
       </p:sp>
@@ -7365,6 +7459,7 @@
           <a:lstStyle/>
           <a:p>
             <a:pPr algn="ctr"/>
+            <a:endParaRPr/>
           </a:p>
         </p:txBody>
       </p:sp>
@@ -7455,11 +7550,41 @@
                 <a:tableStyleId>{5C22544A-7EE6-4342-B048-85BDC9FD1C3A}</a:tableStyleId>
               </a:tblPr>
               <a:tblGrid>
-                <a:gridCol w="3108960"/>
-                <a:gridCol w="2194560"/>
-                <a:gridCol w="1737360"/>
-                <a:gridCol w="1828800"/>
-                <a:gridCol w="1554480"/>
+                <a:gridCol w="3108960">
+                  <a:extLst>
+                    <a:ext uri="{9D8B030D-6E8A-4147-A177-3AD203B41FA5}">
+                      <a16:colId xmlns:a16="http://schemas.microsoft.com/office/drawing/2014/main" val="20000"/>
+                    </a:ext>
+                  </a:extLst>
+                </a:gridCol>
+                <a:gridCol w="2194560">
+                  <a:extLst>
+                    <a:ext uri="{9D8B030D-6E8A-4147-A177-3AD203B41FA5}">
+                      <a16:colId xmlns:a16="http://schemas.microsoft.com/office/drawing/2014/main" val="20001"/>
+                    </a:ext>
+                  </a:extLst>
+                </a:gridCol>
+                <a:gridCol w="1737360">
+                  <a:extLst>
+                    <a:ext uri="{9D8B030D-6E8A-4147-A177-3AD203B41FA5}">
+                      <a16:colId xmlns:a16="http://schemas.microsoft.com/office/drawing/2014/main" val="20002"/>
+                    </a:ext>
+                  </a:extLst>
+                </a:gridCol>
+                <a:gridCol w="1828800">
+                  <a:extLst>
+                    <a:ext uri="{9D8B030D-6E8A-4147-A177-3AD203B41FA5}">
+                      <a16:colId xmlns:a16="http://schemas.microsoft.com/office/drawing/2014/main" val="20003"/>
+                    </a:ext>
+                  </a:extLst>
+                </a:gridCol>
+                <a:gridCol w="1554480">
+                  <a:extLst>
+                    <a:ext uri="{9D8B030D-6E8A-4147-A177-3AD203B41FA5}">
+                      <a16:colId xmlns:a16="http://schemas.microsoft.com/office/drawing/2014/main" val="20004"/>
+                    </a:ext>
+                  </a:extLst>
+                </a:gridCol>
               </a:tblGrid>
               <a:tr h="502920">
                 <a:tc>
@@ -7479,7 +7604,7 @@
                       </a:r>
                     </a:p>
                   </a:txBody>
-                  <a:tcPr anchor="ctr" marL="109728" marR="109728">
+                  <a:tcPr marL="109728" marR="109728" anchor="ctr">
                     <a:solidFill>
                       <a:srgbClr val="13231B"/>
                     </a:solidFill>
@@ -7502,7 +7627,7 @@
                       </a:r>
                     </a:p>
                   </a:txBody>
-                  <a:tcPr anchor="ctr" marL="109728" marR="109728">
+                  <a:tcPr marL="109728" marR="109728" anchor="ctr">
                     <a:solidFill>
                       <a:srgbClr val="13231B"/>
                     </a:solidFill>
@@ -7525,7 +7650,7 @@
                       </a:r>
                     </a:p>
                   </a:txBody>
-                  <a:tcPr anchor="ctr" marL="109728" marR="109728">
+                  <a:tcPr marL="109728" marR="109728" anchor="ctr">
                     <a:solidFill>
                       <a:srgbClr val="13231B"/>
                     </a:solidFill>
@@ -7548,7 +7673,7 @@
                       </a:r>
                     </a:p>
                   </a:txBody>
-                  <a:tcPr anchor="ctr" marL="109728" marR="109728">
+                  <a:tcPr marL="109728" marR="109728" anchor="ctr">
                     <a:solidFill>
                       <a:srgbClr val="13231B"/>
                     </a:solidFill>
@@ -7571,12 +7696,17 @@
                       </a:r>
                     </a:p>
                   </a:txBody>
-                  <a:tcPr anchor="ctr" marL="109728" marR="109728">
+                  <a:tcPr marL="109728" marR="109728" anchor="ctr">
                     <a:solidFill>
                       <a:srgbClr val="13231B"/>
                     </a:solidFill>
                   </a:tcPr>
                 </a:tc>
+                <a:extLst>
+                  <a:ext uri="{0D108BD9-81ED-4DB2-BD59-A6C34878D82A}">
+                    <a16:rowId xmlns:a16="http://schemas.microsoft.com/office/drawing/2014/main" val="10000"/>
+                  </a:ext>
+                </a:extLst>
               </a:tr>
               <a:tr h="502920">
                 <a:tc>
@@ -7596,7 +7726,7 @@
                       </a:r>
                     </a:p>
                   </a:txBody>
-                  <a:tcPr anchor="ctr" marL="109728" marR="109728">
+                  <a:tcPr marL="109728" marR="109728" anchor="ctr">
                     <a:solidFill>
                       <a:srgbClr val="FFFFFF"/>
                     </a:solidFill>
@@ -7619,7 +7749,7 @@
                       </a:r>
                     </a:p>
                   </a:txBody>
-                  <a:tcPr anchor="ctr" marL="109728" marR="109728">
+                  <a:tcPr marL="109728" marR="109728" anchor="ctr">
                     <a:solidFill>
                       <a:srgbClr val="FFFFFF"/>
                     </a:solidFill>
@@ -7642,7 +7772,7 @@
                       </a:r>
                     </a:p>
                   </a:txBody>
-                  <a:tcPr anchor="ctr" marL="109728" marR="109728">
+                  <a:tcPr marL="109728" marR="109728" anchor="ctr">
                     <a:solidFill>
                       <a:srgbClr val="FFFFFF"/>
                     </a:solidFill>
@@ -7665,7 +7795,7 @@
                       </a:r>
                     </a:p>
                   </a:txBody>
-                  <a:tcPr anchor="ctr" marL="109728" marR="109728">
+                  <a:tcPr marL="109728" marR="109728" anchor="ctr">
                     <a:solidFill>
                       <a:srgbClr val="FFFFFF"/>
                     </a:solidFill>
@@ -7688,12 +7818,17 @@
                       </a:r>
                     </a:p>
                   </a:txBody>
-                  <a:tcPr anchor="ctr" marL="109728" marR="109728">
+                  <a:tcPr marL="109728" marR="109728" anchor="ctr">
                     <a:solidFill>
                       <a:srgbClr val="FFFFFF"/>
                     </a:solidFill>
                   </a:tcPr>
                 </a:tc>
+                <a:extLst>
+                  <a:ext uri="{0D108BD9-81ED-4DB2-BD59-A6C34878D82A}">
+                    <a16:rowId xmlns:a16="http://schemas.microsoft.com/office/drawing/2014/main" val="10001"/>
+                  </a:ext>
+                </a:extLst>
               </a:tr>
               <a:tr h="502920">
                 <a:tc>
@@ -7713,7 +7848,7 @@
                       </a:r>
                     </a:p>
                   </a:txBody>
-                  <a:tcPr anchor="ctr" marL="109728" marR="109728">
+                  <a:tcPr marL="109728" marR="109728" anchor="ctr">
                     <a:solidFill>
                       <a:srgbClr val="FFFFFF"/>
                     </a:solidFill>
@@ -7736,7 +7871,7 @@
                       </a:r>
                     </a:p>
                   </a:txBody>
-                  <a:tcPr anchor="ctr" marL="109728" marR="109728">
+                  <a:tcPr marL="109728" marR="109728" anchor="ctr">
                     <a:solidFill>
                       <a:srgbClr val="FFFFFF"/>
                     </a:solidFill>
@@ -7759,7 +7894,7 @@
                       </a:r>
                     </a:p>
                   </a:txBody>
-                  <a:tcPr anchor="ctr" marL="109728" marR="109728">
+                  <a:tcPr marL="109728" marR="109728" anchor="ctr">
                     <a:solidFill>
                       <a:srgbClr val="FFFFFF"/>
                     </a:solidFill>
@@ -7782,7 +7917,7 @@
                       </a:r>
                     </a:p>
                   </a:txBody>
-                  <a:tcPr anchor="ctr" marL="109728" marR="109728">
+                  <a:tcPr marL="109728" marR="109728" anchor="ctr">
                     <a:solidFill>
                       <a:srgbClr val="FFFFFF"/>
                     </a:solidFill>
@@ -7805,12 +7940,17 @@
                       </a:r>
                     </a:p>
                   </a:txBody>
-                  <a:tcPr anchor="ctr" marL="109728" marR="109728">
+                  <a:tcPr marL="109728" marR="109728" anchor="ctr">
                     <a:solidFill>
                       <a:srgbClr val="FFFFFF"/>
                     </a:solidFill>
                   </a:tcPr>
                 </a:tc>
+                <a:extLst>
+                  <a:ext uri="{0D108BD9-81ED-4DB2-BD59-A6C34878D82A}">
+                    <a16:rowId xmlns:a16="http://schemas.microsoft.com/office/drawing/2014/main" val="10002"/>
+                  </a:ext>
+                </a:extLst>
               </a:tr>
               <a:tr h="502920">
                 <a:tc>
@@ -7830,7 +7970,7 @@
                       </a:r>
                     </a:p>
                   </a:txBody>
-                  <a:tcPr anchor="ctr" marL="109728" marR="109728">
+                  <a:tcPr marL="109728" marR="109728" anchor="ctr">
                     <a:solidFill>
                       <a:srgbClr val="FFFFFF"/>
                     </a:solidFill>
@@ -7853,7 +7993,7 @@
                       </a:r>
                     </a:p>
                   </a:txBody>
-                  <a:tcPr anchor="ctr" marL="109728" marR="109728">
+                  <a:tcPr marL="109728" marR="109728" anchor="ctr">
                     <a:solidFill>
                       <a:srgbClr val="FFFFFF"/>
                     </a:solidFill>
@@ -7876,7 +8016,7 @@
                       </a:r>
                     </a:p>
                   </a:txBody>
-                  <a:tcPr anchor="ctr" marL="109728" marR="109728">
+                  <a:tcPr marL="109728" marR="109728" anchor="ctr">
                     <a:solidFill>
                       <a:srgbClr val="FFFFFF"/>
                     </a:solidFill>
@@ -7899,7 +8039,7 @@
                       </a:r>
                     </a:p>
                   </a:txBody>
-                  <a:tcPr anchor="ctr" marL="109728" marR="109728">
+                  <a:tcPr marL="109728" marR="109728" anchor="ctr">
                     <a:solidFill>
                       <a:srgbClr val="FFFFFF"/>
                     </a:solidFill>
@@ -7922,12 +8062,17 @@
                       </a:r>
                     </a:p>
                   </a:txBody>
-                  <a:tcPr anchor="ctr" marL="109728" marR="109728">
+                  <a:tcPr marL="109728" marR="109728" anchor="ctr">
                     <a:solidFill>
                       <a:srgbClr val="FFFFFF"/>
                     </a:solidFill>
                   </a:tcPr>
                 </a:tc>
+                <a:extLst>
+                  <a:ext uri="{0D108BD9-81ED-4DB2-BD59-A6C34878D82A}">
+                    <a16:rowId xmlns:a16="http://schemas.microsoft.com/office/drawing/2014/main" val="10003"/>
+                  </a:ext>
+                </a:extLst>
               </a:tr>
               <a:tr h="502920">
                 <a:tc>
@@ -7947,7 +8092,7 @@
                       </a:r>
                     </a:p>
                   </a:txBody>
-                  <a:tcPr anchor="ctr" marL="109728" marR="109728">
+                  <a:tcPr marL="109728" marR="109728" anchor="ctr">
                     <a:solidFill>
                       <a:srgbClr val="DCEEE1"/>
                     </a:solidFill>
@@ -7970,7 +8115,7 @@
                       </a:r>
                     </a:p>
                   </a:txBody>
-                  <a:tcPr anchor="ctr" marL="109728" marR="109728">
+                  <a:tcPr marL="109728" marR="109728" anchor="ctr">
                     <a:solidFill>
                       <a:srgbClr val="DCEEE1"/>
                     </a:solidFill>
@@ -7993,7 +8138,7 @@
                       </a:r>
                     </a:p>
                   </a:txBody>
-                  <a:tcPr anchor="ctr" marL="109728" marR="109728">
+                  <a:tcPr marL="109728" marR="109728" anchor="ctr">
                     <a:solidFill>
                       <a:srgbClr val="DCEEE1"/>
                     </a:solidFill>
@@ -8016,7 +8161,7 @@
                       </a:r>
                     </a:p>
                   </a:txBody>
-                  <a:tcPr anchor="ctr" marL="109728" marR="109728">
+                  <a:tcPr marL="109728" marR="109728" anchor="ctr">
                     <a:solidFill>
                       <a:srgbClr val="DCEEE1"/>
                     </a:solidFill>
@@ -8039,12 +8184,17 @@
                       </a:r>
                     </a:p>
                   </a:txBody>
-                  <a:tcPr anchor="ctr" marL="109728" marR="109728">
+                  <a:tcPr marL="109728" marR="109728" anchor="ctr">
                     <a:solidFill>
                       <a:srgbClr val="DCEEE1"/>
                     </a:solidFill>
                   </a:tcPr>
                 </a:tc>
+                <a:extLst>
+                  <a:ext uri="{0D108BD9-81ED-4DB2-BD59-A6C34878D82A}">
+                    <a16:rowId xmlns:a16="http://schemas.microsoft.com/office/drawing/2014/main" val="10004"/>
+                  </a:ext>
+                </a:extLst>
               </a:tr>
               <a:tr h="502920">
                 <a:tc>
@@ -8064,7 +8214,7 @@
                       </a:r>
                     </a:p>
                   </a:txBody>
-                  <a:tcPr anchor="ctr" marL="109728" marR="109728">
+                  <a:tcPr marL="109728" marR="109728" anchor="ctr">
                     <a:solidFill>
                       <a:srgbClr val="DCEEE1"/>
                     </a:solidFill>
@@ -8087,7 +8237,7 @@
                       </a:r>
                     </a:p>
                   </a:txBody>
-                  <a:tcPr anchor="ctr" marL="109728" marR="109728">
+                  <a:tcPr marL="109728" marR="109728" anchor="ctr">
                     <a:solidFill>
                       <a:srgbClr val="DCEEE1"/>
                     </a:solidFill>
@@ -8110,7 +8260,7 @@
                       </a:r>
                     </a:p>
                   </a:txBody>
-                  <a:tcPr anchor="ctr" marL="109728" marR="109728">
+                  <a:tcPr marL="109728" marR="109728" anchor="ctr">
                     <a:solidFill>
                       <a:srgbClr val="DCEEE1"/>
                     </a:solidFill>
@@ -8133,7 +8283,7 @@
                       </a:r>
                     </a:p>
                   </a:txBody>
-                  <a:tcPr anchor="ctr" marL="109728" marR="109728">
+                  <a:tcPr marL="109728" marR="109728" anchor="ctr">
                     <a:solidFill>
                       <a:srgbClr val="DCEEE1"/>
                     </a:solidFill>
@@ -8156,12 +8306,17 @@
                       </a:r>
                     </a:p>
                   </a:txBody>
-                  <a:tcPr anchor="ctr" marL="109728" marR="109728">
+                  <a:tcPr marL="109728" marR="109728" anchor="ctr">
                     <a:solidFill>
                       <a:srgbClr val="DCEEE1"/>
                     </a:solidFill>
                   </a:tcPr>
                 </a:tc>
+                <a:extLst>
+                  <a:ext uri="{0D108BD9-81ED-4DB2-BD59-A6C34878D82A}">
+                    <a16:rowId xmlns:a16="http://schemas.microsoft.com/office/drawing/2014/main" val="10005"/>
+                  </a:ext>
+                </a:extLst>
               </a:tr>
               <a:tr h="502920">
                 <a:tc>
@@ -8181,7 +8336,7 @@
                       </a:r>
                     </a:p>
                   </a:txBody>
-                  <a:tcPr anchor="ctr" marL="109728" marR="109728">
+                  <a:tcPr marL="109728" marR="109728" anchor="ctr">
                     <a:solidFill>
                       <a:srgbClr val="FFFFFF"/>
                     </a:solidFill>
@@ -8204,7 +8359,7 @@
                       </a:r>
                     </a:p>
                   </a:txBody>
-                  <a:tcPr anchor="ctr" marL="109728" marR="109728">
+                  <a:tcPr marL="109728" marR="109728" anchor="ctr">
                     <a:solidFill>
                       <a:srgbClr val="FFFFFF"/>
                     </a:solidFill>
@@ -8227,7 +8382,7 @@
                       </a:r>
                     </a:p>
                   </a:txBody>
-                  <a:tcPr anchor="ctr" marL="109728" marR="109728">
+                  <a:tcPr marL="109728" marR="109728" anchor="ctr">
                     <a:solidFill>
                       <a:srgbClr val="FFFFFF"/>
                     </a:solidFill>
@@ -8250,7 +8405,7 @@
                       </a:r>
                     </a:p>
                   </a:txBody>
-                  <a:tcPr anchor="ctr" marL="109728" marR="109728">
+                  <a:tcPr marL="109728" marR="109728" anchor="ctr">
                     <a:solidFill>
                       <a:srgbClr val="FFFFFF"/>
                     </a:solidFill>
@@ -8273,12 +8428,17 @@
                       </a:r>
                     </a:p>
                   </a:txBody>
-                  <a:tcPr anchor="ctr" marL="109728" marR="109728">
+                  <a:tcPr marL="109728" marR="109728" anchor="ctr">
                     <a:solidFill>
                       <a:srgbClr val="FFFFFF"/>
                     </a:solidFill>
                   </a:tcPr>
                 </a:tc>
+                <a:extLst>
+                  <a:ext uri="{0D108BD9-81ED-4DB2-BD59-A6C34878D82A}">
+                    <a16:rowId xmlns:a16="http://schemas.microsoft.com/office/drawing/2014/main" val="10006"/>
+                  </a:ext>
+                </a:extLst>
               </a:tr>
               <a:tr h="502920">
                 <a:tc>
@@ -8298,7 +8458,7 @@
                       </a:r>
                     </a:p>
                   </a:txBody>
-                  <a:tcPr anchor="ctr" marL="109728" marR="109728">
+                  <a:tcPr marL="109728" marR="109728" anchor="ctr">
                     <a:solidFill>
                       <a:srgbClr val="FFFFFF"/>
                     </a:solidFill>
@@ -8321,7 +8481,7 @@
                       </a:r>
                     </a:p>
                   </a:txBody>
-                  <a:tcPr anchor="ctr" marL="109728" marR="109728">
+                  <a:tcPr marL="109728" marR="109728" anchor="ctr">
                     <a:solidFill>
                       <a:srgbClr val="FFFFFF"/>
                     </a:solidFill>
@@ -8344,7 +8504,7 @@
                       </a:r>
                     </a:p>
                   </a:txBody>
-                  <a:tcPr anchor="ctr" marL="109728" marR="109728">
+                  <a:tcPr marL="109728" marR="109728" anchor="ctr">
                     <a:solidFill>
                       <a:srgbClr val="FFFFFF"/>
                     </a:solidFill>
@@ -8367,7 +8527,7 @@
                       </a:r>
                     </a:p>
                   </a:txBody>
-                  <a:tcPr anchor="ctr" marL="109728" marR="109728">
+                  <a:tcPr marL="109728" marR="109728" anchor="ctr">
                     <a:solidFill>
                       <a:srgbClr val="FFFFFF"/>
                     </a:solidFill>
@@ -8390,12 +8550,17 @@
                       </a:r>
                     </a:p>
                   </a:txBody>
-                  <a:tcPr anchor="ctr" marL="109728" marR="109728">
+                  <a:tcPr marL="109728" marR="109728" anchor="ctr">
                     <a:solidFill>
                       <a:srgbClr val="FFFFFF"/>
                     </a:solidFill>
                   </a:tcPr>
                 </a:tc>
+                <a:extLst>
+                  <a:ext uri="{0D108BD9-81ED-4DB2-BD59-A6C34878D82A}">
+                    <a16:rowId xmlns:a16="http://schemas.microsoft.com/office/drawing/2014/main" val="10007"/>
+                  </a:ext>
+                </a:extLst>
               </a:tr>
             </a:tbl>
           </a:graphicData>
@@ -8445,7 +8610,7 @@
 </file>
 
 <file path=ppt/slides/slide9.xml><?xml version="1.0" encoding="utf-8"?>
-<p:sld xmlns:a="http://schemas.openxmlformats.org/drawingml/2006/main" xmlns:p="http://schemas.openxmlformats.org/presentationml/2006/main" xmlns:r="http://schemas.openxmlformats.org/officeDocument/2006/relationships">
+<p:sld xmlns:a="http://schemas.openxmlformats.org/drawingml/2006/main" xmlns:r="http://schemas.openxmlformats.org/officeDocument/2006/relationships" xmlns:p="http://schemas.openxmlformats.org/presentationml/2006/main">
   <p:cSld>
     <p:spTree>
       <p:nvGrpSpPr>
@@ -8453,7 +8618,14 @@
         <p:cNvGrpSpPr/>
         <p:nvPr/>
       </p:nvGrpSpPr>
-      <p:grpSpPr/>
+      <p:grpSpPr>
+        <a:xfrm>
+          <a:off x="0" y="0"/>
+          <a:ext cx="0" cy="0"/>
+          <a:chOff x="0" y="0"/>
+          <a:chExt cx="0" cy="0"/>
+        </a:xfrm>
+      </p:grpSpPr>
       <p:sp>
         <p:nvSpPr>
           <p:cNvPr id="2" name="Rectangle 1"/>
@@ -8495,6 +8667,7 @@
           <a:lstStyle/>
           <a:p>
             <a:pPr algn="ctr"/>
+            <a:endParaRPr/>
           </a:p>
         </p:txBody>
       </p:sp>
@@ -8539,6 +8712,7 @@
           <a:lstStyle/>
           <a:p>
             <a:pPr algn="ctr"/>
+            <a:endParaRPr/>
           </a:p>
         </p:txBody>
       </p:sp>
@@ -8653,6 +8827,7 @@
           <a:lstStyle/>
           <a:p>
             <a:pPr algn="ctr"/>
+            <a:endParaRPr/>
           </a:p>
         </p:txBody>
       </p:sp>

</xml_diff>